<commit_message>
feat: refine portfolio presentation and resume
</commit_message>
<xml_diff>
--- a/assets/presentations/healthy-eating-presentation.pptx
+++ b/assets/presentations/healthy-eating-presentation.pptx
@@ -18609,7 +18609,7 @@
                 <a:cs typeface="Microsoft JhengHei"/>
                 <a:sym typeface="Microsoft JhengHei"/>
               </a:rPr>
-              <a:t>第八組｜高婉瑜・劉婉萱・王洺方</a:t>
+              <a:t>團體專案｜第八組</a:t>
             </a:r>
             <a:r>
               <a:rPr lang="en-US" sz="1600">
@@ -18621,7 +18621,7 @@
                 <a:cs typeface="Microsoft JhengHei"/>
                 <a:sym typeface="Microsoft JhengHei"/>
               </a:rPr>
-              <a:t>・傅品蓉</a:t>
+              <a:t/>
             </a:r>
             <a:endParaRPr b="0" i="0" sz="1400" u="none" cap="none" strike="noStrike">
               <a:solidFill>

</xml_diff>